<commit_message>
add: update HighBits example
</commit_message>
<xml_diff>
--- a/presentation/0813_12_Dilithium-t-Compression-and-Full-Scheme.pptx
+++ b/presentation/0813_12_Dilithium-t-Compression-and-Full-Scheme.pptx
@@ -240,7 +240,7 @@
           <a:p>
             <a:fld id="{B52B40C2-3351-40A2-B46D-4B4F877A79B2}" type="datetimeFigureOut">
               <a:rPr lang="ko-KR" altLang="en-US" smtClean="0"/>
-              <a:t>2026-08-13</a:t>
+              <a:t>2026-08-20</a:t>
             </a:fld>
             <a:endParaRPr lang="ko-KR" altLang="en-US" dirty="0"/>
           </a:p>
@@ -668,7 +668,7 @@
           <a:p>
             <a:fld id="{2ADF637E-82D6-4563-BCF0-C9101F2B5148}" type="datetime1">
               <a:rPr lang="ko-KR" altLang="en-US" smtClean="0"/>
-              <a:t>2026-08-13</a:t>
+              <a:t>2026-08-20</a:t>
             </a:fld>
             <a:endParaRPr lang="ko-KR" altLang="en-US" dirty="0"/>
           </a:p>
@@ -866,7 +866,7 @@
           <a:p>
             <a:fld id="{C9178607-39E6-4CB2-B3CB-AB428B3B6195}" type="datetime1">
               <a:rPr lang="ko-KR" altLang="en-US" smtClean="0"/>
-              <a:t>2026-08-13</a:t>
+              <a:t>2026-08-20</a:t>
             </a:fld>
             <a:endParaRPr lang="ko-KR" altLang="en-US" dirty="0"/>
           </a:p>
@@ -1074,7 +1074,7 @@
           <a:p>
             <a:fld id="{F578A2F2-325F-46A6-8956-F2A49A35BAF8}" type="datetime1">
               <a:rPr lang="ko-KR" altLang="en-US" smtClean="0"/>
-              <a:t>2026-08-13</a:t>
+              <a:t>2026-08-20</a:t>
             </a:fld>
             <a:endParaRPr lang="ko-KR" altLang="en-US" dirty="0"/>
           </a:p>
@@ -1321,7 +1321,7 @@
           <a:p>
             <a:fld id="{D58CD677-7AD2-4A27-94BD-C65458D22428}" type="datetime1">
               <a:rPr lang="ko-KR" altLang="en-US" smtClean="0"/>
-              <a:t>2026-08-13</a:t>
+              <a:t>2026-08-20</a:t>
             </a:fld>
             <a:endParaRPr lang="ko-KR" altLang="en-US" dirty="0"/>
           </a:p>
@@ -1646,7 +1646,7 @@
           <a:p>
             <a:fld id="{2BEF52EC-B397-4D0A-AE91-E0D6840C85A1}" type="datetime1">
               <a:rPr lang="ko-KR" altLang="en-US" smtClean="0"/>
-              <a:t>2026-08-13</a:t>
+              <a:t>2026-08-20</a:t>
             </a:fld>
             <a:endParaRPr lang="ko-KR" altLang="en-US" dirty="0"/>
           </a:p>
@@ -1911,7 +1911,7 @@
           <a:p>
             <a:fld id="{32DD6007-6A42-4C9B-B218-6A32B3A38C67}" type="datetime1">
               <a:rPr lang="ko-KR" altLang="en-US" smtClean="0"/>
-              <a:t>2026-08-13</a:t>
+              <a:t>2026-08-20</a:t>
             </a:fld>
             <a:endParaRPr lang="ko-KR" altLang="en-US" dirty="0"/>
           </a:p>
@@ -2323,7 +2323,7 @@
           <a:p>
             <a:fld id="{F66658DF-8B5F-4351-A42C-BF3495DE7ABE}" type="datetime1">
               <a:rPr lang="ko-KR" altLang="en-US" smtClean="0"/>
-              <a:t>2026-08-13</a:t>
+              <a:t>2026-08-20</a:t>
             </a:fld>
             <a:endParaRPr lang="ko-KR" altLang="en-US" dirty="0"/>
           </a:p>
@@ -2464,7 +2464,7 @@
           <a:p>
             <a:fld id="{74359C48-8150-4FAB-8BEF-6AD61CFC9BBE}" type="datetime1">
               <a:rPr lang="ko-KR" altLang="en-US" smtClean="0"/>
-              <a:t>2026-08-13</a:t>
+              <a:t>2026-08-20</a:t>
             </a:fld>
             <a:endParaRPr lang="ko-KR" altLang="en-US" dirty="0"/>
           </a:p>
@@ -2577,7 +2577,7 @@
           <a:p>
             <a:fld id="{2D41DBCF-1091-470D-AC72-5CF3D00280AC}" type="datetime1">
               <a:rPr lang="ko-KR" altLang="en-US" smtClean="0"/>
-              <a:t>2026-08-13</a:t>
+              <a:t>2026-08-20</a:t>
             </a:fld>
             <a:endParaRPr lang="ko-KR" altLang="en-US" dirty="0"/>
           </a:p>
@@ -2888,7 +2888,7 @@
           <a:p>
             <a:fld id="{4024AE7C-57FB-4DBB-B90C-59145D637BF6}" type="datetime1">
               <a:rPr lang="ko-KR" altLang="en-US" smtClean="0"/>
-              <a:t>2026-08-13</a:t>
+              <a:t>2026-08-20</a:t>
             </a:fld>
             <a:endParaRPr lang="ko-KR" altLang="en-US" dirty="0"/>
           </a:p>
@@ -3176,7 +3176,7 @@
           <a:p>
             <a:fld id="{17D92253-43A0-46E3-918E-3929407A8C01}" type="datetime1">
               <a:rPr lang="ko-KR" altLang="en-US" smtClean="0"/>
-              <a:t>2026-08-13</a:t>
+              <a:t>2026-08-20</a:t>
             </a:fld>
             <a:endParaRPr lang="ko-KR" altLang="en-US" dirty="0"/>
           </a:p>
@@ -3417,7 +3417,7 @@
           <a:p>
             <a:fld id="{75D61A29-800E-482A-B0FD-5A04401ECD92}" type="datetime1">
               <a:rPr lang="ko-KR" altLang="en-US" smtClean="0"/>
-              <a:t>2026-08-13</a:t>
+              <a:t>2026-08-20</a:t>
             </a:fld>
             <a:endParaRPr lang="ko-KR" altLang="en-US" dirty="0"/>
           </a:p>
@@ -3985,19 +3985,7 @@
                       <a:rPr lang="en-US" i="1">
                         <a:latin typeface="Cambria Math"/>
                       </a:rPr>
-                      <m:t>=</m:t>
-                    </m:r>
-                    <m:r>
-                      <a:rPr lang="en-US" i="1">
-                        <a:latin typeface="Cambria Math"/>
-                      </a:rPr>
-                      <m:t>13</m:t>
-                    </m:r>
-                    <m:r>
-                      <a:rPr lang="en-US" i="1">
-                        <a:latin typeface="Cambria Math"/>
-                      </a:rPr>
-                      <m:t>,</m:t>
+                      <m:t>=13,</m:t>
                     </m:r>
                     <m:r>
                       <a:rPr lang="en-US" i="1">
@@ -4009,19 +3997,7 @@
                       <a:rPr lang="en-US" i="1">
                         <a:latin typeface="Cambria Math"/>
                       </a:rPr>
-                      <m:t>=</m:t>
-                    </m:r>
-                    <m:r>
-                      <a:rPr lang="en-US" i="1">
-                        <a:latin typeface="Cambria Math"/>
-                      </a:rPr>
-                      <m:t>60</m:t>
-                    </m:r>
-                    <m:r>
-                      <a:rPr lang="en-US" i="1">
-                        <a:latin typeface="Cambria Math"/>
-                      </a:rPr>
-                      <m:t>,</m:t>
+                      <m:t>=60,</m:t>
                     </m:r>
                     <m:sSub>
                       <m:sSubPr>
@@ -4052,25 +4028,7 @@
                       <a:rPr lang="en-US" i="1">
                         <a:latin typeface="Cambria Math"/>
                       </a:rPr>
-                      <m:t>=</m:t>
-                    </m:r>
-                    <m:r>
-                      <a:rPr lang="en-US" i="1">
-                        <a:latin typeface="Cambria Math"/>
-                      </a:rPr>
-                      <m:t>261</m:t>
-                    </m:r>
-                    <m:r>
-                      <a:rPr lang="en-US" i="1">
-                        <a:latin typeface="Cambria Math"/>
-                      </a:rPr>
-                      <m:t>,</m:t>
-                    </m:r>
-                    <m:r>
-                      <a:rPr lang="en-US" i="1">
-                        <a:latin typeface="Cambria Math"/>
-                      </a:rPr>
-                      <m:t>888</m:t>
+                      <m:t>=261,888</m:t>
                     </m:r>
                   </m:oMath>
                 </a14:m>
@@ -4122,13 +4080,7 @@
                           <a:rPr lang="en-US" i="1">
                             <a:latin typeface="Cambria Math"/>
                           </a:rPr>
-                          <m:t>−</m:t>
-                        </m:r>
-                        <m:r>
-                          <a:rPr lang="en-US" i="1">
-                            <a:latin typeface="Cambria Math"/>
-                          </a:rPr>
-                          <m:t>1</m:t>
+                          <m:t>−1</m:t>
                         </m:r>
                       </m:sup>
                     </m:sSup>
@@ -4165,13 +4117,7 @@
                           <a:rPr lang="en-US" i="1">
                             <a:latin typeface="Cambria Math"/>
                           </a:rPr>
-                          <m:t>−</m:t>
-                        </m:r>
-                        <m:r>
-                          <a:rPr lang="en-US" i="1">
-                            <a:latin typeface="Cambria Math"/>
-                          </a:rPr>
-                          <m:t>1</m:t>
+                          <m:t>−1</m:t>
                         </m:r>
                       </m:sup>
                     </m:sSup>
@@ -4179,31 +4125,7 @@
                       <a:rPr lang="en-US" i="1">
                         <a:latin typeface="Cambria Math"/>
                       </a:rPr>
-                      <m:t>]=(−</m:t>
-                    </m:r>
-                    <m:r>
-                      <a:rPr lang="en-US" i="1">
-                        <a:latin typeface="Cambria Math"/>
-                      </a:rPr>
-                      <m:t>4096</m:t>
-                    </m:r>
-                    <m:r>
-                      <a:rPr lang="en-US" i="1">
-                        <a:latin typeface="Cambria Math"/>
-                      </a:rPr>
-                      <m:t>,</m:t>
-                    </m:r>
-                    <m:r>
-                      <a:rPr lang="en-US" i="1">
-                        <a:latin typeface="Cambria Math"/>
-                      </a:rPr>
-                      <m:t>4096</m:t>
-                    </m:r>
-                    <m:r>
-                      <a:rPr lang="en-US" i="1">
-                        <a:latin typeface="Cambria Math"/>
-                      </a:rPr>
-                      <m:t>]</m:t>
+                      <m:t>]=(−4096,4096]</m:t>
                     </m:r>
                   </m:oMath>
                 </a14:m>
@@ -4294,55 +4216,7 @@
                         <a:rPr lang="en-US" i="1">
                           <a:latin typeface="Cambria Math"/>
                         </a:rPr>
-                        <m:t>≤</m:t>
-                      </m:r>
-                      <m:r>
-                        <a:rPr lang="en-US" i="1">
-                          <a:latin typeface="Cambria Math"/>
-                        </a:rPr>
-                        <m:t>60</m:t>
-                      </m:r>
-                      <m:r>
-                        <a:rPr lang="en-US" i="1">
-                          <a:latin typeface="Cambria Math"/>
-                        </a:rPr>
-                        <m:t>×</m:t>
-                      </m:r>
-                      <m:r>
-                        <a:rPr lang="en-US" i="1">
-                          <a:latin typeface="Cambria Math"/>
-                        </a:rPr>
-                        <m:t>4096</m:t>
-                      </m:r>
-                      <m:r>
-                        <a:rPr lang="en-US" i="1">
-                          <a:latin typeface="Cambria Math"/>
-                        </a:rPr>
-                        <m:t>=</m:t>
-                      </m:r>
-                      <m:r>
-                        <a:rPr lang="en-US" i="1">
-                          <a:latin typeface="Cambria Math"/>
-                        </a:rPr>
-                        <m:t>245</m:t>
-                      </m:r>
-                      <m:r>
-                        <a:rPr lang="en-US" i="1">
-                          <a:latin typeface="Cambria Math"/>
-                        </a:rPr>
-                        <m:t>,</m:t>
-                      </m:r>
-                      <m:r>
-                        <a:rPr lang="en-US" i="1">
-                          <a:latin typeface="Cambria Math"/>
-                        </a:rPr>
-                        <m:t>760</m:t>
-                      </m:r>
-                      <m:r>
-                        <a:rPr lang="en-US" i="1">
-                          <a:latin typeface="Cambria Math"/>
-                        </a:rPr>
-                        <m:t>&lt;</m:t>
+                        <m:t>≤60×4096=245,760&lt;</m:t>
                       </m:r>
                       <m:sSub>
                         <m:sSubPr>
@@ -4373,25 +4247,7 @@
                         <a:rPr lang="en-US" i="1">
                           <a:latin typeface="Cambria Math"/>
                         </a:rPr>
-                        <m:t>=</m:t>
-                      </m:r>
-                      <m:r>
-                        <a:rPr lang="en-US" i="1">
-                          <a:latin typeface="Cambria Math"/>
-                        </a:rPr>
-                        <m:t>261</m:t>
-                      </m:r>
-                      <m:r>
-                        <a:rPr lang="en-US" i="1">
-                          <a:latin typeface="Cambria Math"/>
-                        </a:rPr>
-                        <m:t>,</m:t>
-                      </m:r>
-                      <m:r>
-                        <a:rPr lang="en-US" i="1">
-                          <a:latin typeface="Cambria Math"/>
-                        </a:rPr>
-                        <m:t>888</m:t>
+                        <m:t>=261,888</m:t>
                       </m:r>
                     </m:oMath>
                   </m:oMathPara>
@@ -4627,8 +4483,8 @@
           </a:p>
         </p:txBody>
       </p:sp>
-      <mc:AlternateContent xmlns:mc="http://schemas.openxmlformats.org/markup-compatibility/2006" xmlns:a14="http://schemas.microsoft.com/office/drawing/2010/main">
-        <mc:Choice Requires="a14">
+      <mc:AlternateContent xmlns:mc="http://schemas.openxmlformats.org/markup-compatibility/2006">
+        <mc:Choice xmlns:a14="http://schemas.microsoft.com/office/drawing/2010/main" Requires="a14">
           <p:sp>
             <p:nvSpPr>
               <p:cNvPr id="3" name="Content Placeholder 2"/>
@@ -4651,7 +4507,15 @@
               <a:p>
                 <a:r>
                   <a:rPr dirty="0"/>
-                  <a:t>‖−ct0‖∞ ≤ γ2일 때, </a:t>
+                  <a:t>‖−ct</a:t>
+                </a:r>
+                <a:r>
+                  <a:rPr baseline="-25000" dirty="0"/>
+                  <a:t>0</a:t>
+                </a:r>
+                <a:r>
+                  <a:rPr dirty="0"/>
+                  <a:t>‖∞ ≤ γ2일 때, </a:t>
                 </a:r>
                 <a14:m>
                   <m:oMath xmlns:m="http://schemas.openxmlformats.org/officeDocument/2006/math">
@@ -4841,7 +4705,7 @@
             </p:txBody>
           </p:sp>
         </mc:Choice>
-        <mc:Fallback xmlns="">
+        <mc:Fallback>
           <p:sp>
             <p:nvSpPr>
               <p:cNvPr id="3" name="Content Placeholder 2"/>
@@ -4860,7 +4724,7 @@
               <a:blipFill>
                 <a:blip r:embed="rId2"/>
                 <a:stretch>
-                  <a:fillRect l="-406" r="-58"/>
+                  <a:fillRect l="-406" r="-464"/>
                 </a:stretch>
               </a:blipFill>
             </p:spPr>
@@ -7013,7 +6877,19 @@
                       <a:rPr lang="en-US" i="1">
                         <a:latin typeface="Cambria Math"/>
                       </a:rPr>
-                      <m:t>∈[0,</m:t>
+                      <m:t>∈[</m:t>
+                    </m:r>
+                    <m:r>
+                      <a:rPr lang="en-US" i="1">
+                        <a:latin typeface="Cambria Math"/>
+                      </a:rPr>
+                      <m:t>0</m:t>
+                    </m:r>
+                    <m:r>
+                      <a:rPr lang="en-US" i="1">
+                        <a:latin typeface="Cambria Math"/>
+                      </a:rPr>
+                      <m:t>,</m:t>
                     </m:r>
                     <m:r>
                       <a:rPr lang="en-US" i="1">
@@ -7025,7 +6901,19 @@
                       <a:rPr lang="en-US" i="1">
                         <a:latin typeface="Cambria Math"/>
                       </a:rPr>
-                      <m:t>−1],−</m:t>
+                      <m:t>−</m:t>
+                    </m:r>
+                    <m:r>
+                      <a:rPr lang="en-US" i="1">
+                        <a:latin typeface="Cambria Math"/>
+                      </a:rPr>
+                      <m:t>1</m:t>
+                    </m:r>
+                    <m:r>
+                      <a:rPr lang="en-US" i="1">
+                        <a:latin typeface="Cambria Math"/>
+                      </a:rPr>
+                      <m:t>],−</m:t>
                     </m:r>
                     <m:r>
                       <a:rPr lang="en-US" i="1">
@@ -7037,7 +6925,19 @@
                       <a:rPr lang="en-US" i="1">
                         <a:latin typeface="Cambria Math"/>
                       </a:rPr>
-                      <m:t>/2≤</m:t>
+                      <m:t>/</m:t>
+                    </m:r>
+                    <m:r>
+                      <a:rPr lang="en-US" i="1">
+                        <a:latin typeface="Cambria Math"/>
+                      </a:rPr>
+                      <m:t>2</m:t>
+                    </m:r>
+                    <m:r>
+                      <a:rPr lang="en-US" i="1">
+                        <a:latin typeface="Cambria Math"/>
+                      </a:rPr>
+                      <m:t>≤</m:t>
                     </m:r>
                     <m:r>
                       <a:rPr lang="en-US" i="1">
@@ -7061,7 +6961,13 @@
                       <a:rPr lang="en-US" i="1">
                         <a:latin typeface="Cambria Math"/>
                       </a:rPr>
-                      <m:t>/2</m:t>
+                      <m:t>/</m:t>
+                    </m:r>
+                    <m:r>
+                      <a:rPr lang="en-US" i="1">
+                        <a:latin typeface="Cambria Math"/>
+                      </a:rPr>
+                      <m:t>2</m:t>
                     </m:r>
                   </m:oMath>
                 </a14:m>
@@ -7123,7 +7029,13 @@
                                   <a:rPr lang="en-US" i="1">
                                     <a:latin typeface="Cambria Math"/>
                                   </a:rPr>
-                                  <m:t>1,</m:t>
+                                  <m:t>1</m:t>
+                                </m:r>
+                                <m:r>
+                                  <a:rPr lang="en-US" i="1">
+                                    <a:latin typeface="Cambria Math"/>
+                                  </a:rPr>
+                                  <m:t>,</m:t>
                                 </m:r>
                               </m:e>
                               <m:e>
@@ -7225,7 +7137,13 @@
                                   <a:rPr lang="en-US" i="1">
                                     <a:latin typeface="Cambria Math"/>
                                   </a:rPr>
-                                  <m:t>0,</m:t>
+                                  <m:t>0</m:t>
+                                </m:r>
+                                <m:r>
+                                  <a:rPr lang="en-US" i="1">
+                                    <a:latin typeface="Cambria Math"/>
+                                  </a:rPr>
+                                  <m:t>,</m:t>
                                 </m:r>
                               </m:e>
                               <m:e>
@@ -9671,8 +9589,8 @@
           </a:p>
         </p:txBody>
       </p:sp>
-      <mc:AlternateContent xmlns:mc="http://schemas.openxmlformats.org/markup-compatibility/2006">
-        <mc:Choice xmlns:a14="http://schemas.microsoft.com/office/drawing/2010/main" Requires="a14">
+      <mc:AlternateContent xmlns:mc="http://schemas.openxmlformats.org/markup-compatibility/2006" xmlns:a14="http://schemas.microsoft.com/office/drawing/2010/main">
+        <mc:Choice Requires="a14">
           <p:sp>
             <p:nvSpPr>
               <p:cNvPr id="3" name="Content Placeholder 2"/>
@@ -10650,7 +10568,7 @@
             </p:txBody>
           </p:sp>
         </mc:Choice>
-        <mc:Fallback>
+        <mc:Fallback xmlns="">
           <p:sp>
             <p:nvSpPr>
               <p:cNvPr id="3" name="Content Placeholder 2"/>
@@ -14876,13 +14794,7 @@
                         <a:rPr lang="en-US" i="1">
                           <a:latin typeface="Cambria Math"/>
                         </a:rPr>
-                        <m:t>,</m:t>
-                      </m:r>
-                      <m:r>
-                        <a:rPr lang="en-US" i="1">
-                          <a:latin typeface="Cambria Math"/>
-                        </a:rPr>
-                        <m:t>2</m:t>
+                        <m:t>,2</m:t>
                       </m:r>
                       <m:sSub>
                         <m:sSubPr>
@@ -15045,13 +14957,7 @@
                         <a:rPr lang="en-US" i="1">
                           <a:latin typeface="Cambria Math"/>
                         </a:rPr>
-                        <m:t>,</m:t>
-                      </m:r>
-                      <m:r>
-                        <a:rPr lang="en-US" i="1">
-                          <a:latin typeface="Cambria Math"/>
-                        </a:rPr>
-                        <m:t>2</m:t>
+                        <m:t>,2</m:t>
                       </m:r>
                       <m:sSub>
                         <m:sSubPr>
@@ -15142,13 +15048,7 @@
                         <a:rPr lang="en-US" i="1">
                           <a:latin typeface="Cambria Math"/>
                         </a:rPr>
-                        <m:t>,</m:t>
-                      </m:r>
-                      <m:r>
-                        <a:rPr lang="en-US" i="1">
-                          <a:latin typeface="Cambria Math"/>
-                        </a:rPr>
-                        <m:t>2</m:t>
+                        <m:t>,2</m:t>
                       </m:r>
                       <m:sSub>
                         <m:sSubPr>
@@ -15243,13 +15143,7 @@
                         <a:rPr lang="en-US" i="1">
                           <a:latin typeface="Cambria Math"/>
                         </a:rPr>
-                        <m:t>,</m:t>
-                      </m:r>
-                      <m:r>
-                        <a:rPr lang="en-US" i="1">
-                          <a:latin typeface="Cambria Math"/>
-                        </a:rPr>
-                        <m:t>2</m:t>
+                        <m:t>,2</m:t>
                       </m:r>
                       <m:sSub>
                         <m:sSubPr>
@@ -15362,13 +15256,7 @@
                       <a:rPr lang="en-US" i="1">
                         <a:latin typeface="Cambria Math"/>
                       </a:rPr>
-                      <m:t>,</m:t>
-                    </m:r>
-                    <m:r>
-                      <a:rPr lang="en-US" i="1">
-                        <a:latin typeface="Cambria Math"/>
-                      </a:rPr>
-                      <m:t>2</m:t>
+                      <m:t>,2</m:t>
                     </m:r>
                     <m:sSub>
                       <m:sSubPr>
@@ -15621,13 +15509,7 @@
                       <a:rPr lang="en-US" i="1">
                         <a:latin typeface="Cambria Math"/>
                       </a:rPr>
-                      <m:t>,</m:t>
-                    </m:r>
-                    <m:r>
-                      <a:rPr lang="en-US" i="1">
-                        <a:latin typeface="Cambria Math"/>
-                      </a:rPr>
-                      <m:t>2</m:t>
+                      <m:t>,2</m:t>
                     </m:r>
                     <m:sSub>
                       <m:sSubPr>
@@ -15685,13 +15567,7 @@
                       <a:rPr lang="en-US" i="1">
                         <a:latin typeface="Cambria Math"/>
                       </a:rPr>
-                      <m:t>,</m:t>
-                    </m:r>
-                    <m:r>
-                      <a:rPr lang="en-US" i="1">
-                        <a:latin typeface="Cambria Math"/>
-                      </a:rPr>
-                      <m:t>2</m:t>
+                      <m:t>,2</m:t>
                     </m:r>
                     <m:sSub>
                       <m:sSubPr>
@@ -25166,7 +25042,19 @@
                       <a:rPr lang="en-US" i="1">
                         <a:latin typeface="Cambria Math"/>
                       </a:rPr>
-                      <m:t>∈[0,</m:t>
+                      <m:t>∈[</m:t>
+                    </m:r>
+                    <m:r>
+                      <a:rPr lang="en-US" i="1">
+                        <a:latin typeface="Cambria Math"/>
+                      </a:rPr>
+                      <m:t>0</m:t>
+                    </m:r>
+                    <m:r>
+                      <a:rPr lang="en-US" i="1">
+                        <a:latin typeface="Cambria Math"/>
+                      </a:rPr>
+                      <m:t>,</m:t>
                     </m:r>
                     <m:r>
                       <a:rPr lang="en-US" i="1">
@@ -25178,7 +25066,19 @@
                       <a:rPr lang="en-US" i="1">
                         <a:latin typeface="Cambria Math"/>
                       </a:rPr>
-                      <m:t>−1]</m:t>
+                      <m:t>−</m:t>
+                    </m:r>
+                    <m:r>
+                      <a:rPr lang="en-US" i="1">
+                        <a:latin typeface="Cambria Math"/>
+                      </a:rPr>
+                      <m:t>1</m:t>
+                    </m:r>
+                    <m:r>
+                      <a:rPr lang="en-US" i="1">
+                        <a:latin typeface="Cambria Math"/>
+                      </a:rPr>
+                      <m:t>]</m:t>
                     </m:r>
                   </m:oMath>
                 </a14:m>
@@ -25198,7 +25098,19 @@
                       <a:rPr lang="en-US" i="1">
                         <a:latin typeface="Cambria Math"/>
                       </a:rPr>
-                      <m:t>∈[1,</m:t>
+                      <m:t>∈[</m:t>
+                    </m:r>
+                    <m:r>
+                      <a:rPr lang="en-US" i="1">
+                        <a:latin typeface="Cambria Math"/>
+                      </a:rPr>
+                      <m:t>1</m:t>
+                    </m:r>
+                    <m:r>
+                      <a:rPr lang="en-US" i="1">
+                        <a:latin typeface="Cambria Math"/>
+                      </a:rPr>
+                      <m:t>,</m:t>
                     </m:r>
                     <m:sSub>
                       <m:sSubPr>
@@ -25468,7 +25380,13 @@
                             <a:rPr lang="en-US" i="1">
                               <a:latin typeface="Cambria Math"/>
                             </a:rPr>
-                            <m:t>−1</m:t>
+                            <m:t>−</m:t>
+                          </m:r>
+                          <m:r>
+                            <a:rPr lang="en-US" i="1">
+                              <a:latin typeface="Cambria Math"/>
+                            </a:rPr>
+                            <m:t>1</m:t>
                           </m:r>
                         </m:sup>
                       </m:sSup>
@@ -25536,7 +25454,13 @@
                             <a:rPr lang="en-US" i="1">
                               <a:latin typeface="Cambria Math"/>
                             </a:rPr>
-                            <m:t>−1</m:t>
+                            <m:t>−</m:t>
+                          </m:r>
+                          <m:r>
+                            <a:rPr lang="en-US" i="1">
+                              <a:latin typeface="Cambria Math"/>
+                            </a:rPr>
+                            <m:t>1</m:t>
                           </m:r>
                         </m:sup>
                       </m:sSup>
@@ -25544,7 +25468,19 @@
                         <a:rPr lang="en-US" i="1">
                           <a:latin typeface="Cambria Math"/>
                         </a:rPr>
-                        <m:t>,0≤</m:t>
+                        <m:t>,</m:t>
+                      </m:r>
+                      <m:r>
+                        <a:rPr lang="en-US" i="1">
+                          <a:latin typeface="Cambria Math"/>
+                        </a:rPr>
+                        <m:t>0</m:t>
+                      </m:r>
+                      <m:r>
+                        <a:rPr lang="en-US" i="1">
+                          <a:latin typeface="Cambria Math"/>
+                        </a:rPr>
+                        <m:t>≤</m:t>
                       </m:r>
                       <m:sSub>
                         <m:sSubPr>
@@ -25604,7 +25540,19 @@
                             <a:rPr lang="en-US" i="1">
                               <a:latin typeface="Cambria Math"/>
                             </a:rPr>
-                            <m:t>−1)/</m:t>
+                            <m:t>−</m:t>
+                          </m:r>
+                          <m:r>
+                            <a:rPr lang="en-US" i="1">
+                              <a:latin typeface="Cambria Math"/>
+                            </a:rPr>
+                            <m:t>1</m:t>
+                          </m:r>
+                          <m:r>
+                            <a:rPr lang="en-US" i="1">
+                              <a:latin typeface="Cambria Math"/>
+                            </a:rPr>
+                            <m:t>)/</m:t>
                           </m:r>
                           <m:sSup>
                             <m:sSupPr>

</xml_diff>

<commit_message>
add: modify slide 9
</commit_message>
<xml_diff>
--- a/presentation/0813_12_Dilithium-t-Compression-and-Full-Scheme.pptx
+++ b/presentation/0813_12_Dilithium-t-Compression-and-Full-Scheme.pptx
@@ -6050,13 +6050,7 @@
                       <a:rPr lang="en-US" i="1">
                         <a:latin typeface="Cambria Math"/>
                       </a:rPr>
-                      <m:t>−</m:t>
-                    </m:r>
-                    <m:r>
-                      <a:rPr lang="en-US" i="1">
-                        <a:latin typeface="Cambria Math"/>
-                      </a:rPr>
-                      <m:t>1</m:t>
+                      <m:t>−1</m:t>
                     </m:r>
                   </m:oMath>
                 </a14:m>
@@ -6095,19 +6089,7 @@
                       <a:rPr lang="en-US" i="1">
                         <a:latin typeface="Cambria Math"/>
                       </a:rPr>
-                      <m:t>=</m:t>
-                    </m:r>
-                    <m:r>
-                      <a:rPr lang="en-US" i="1">
-                        <a:latin typeface="Cambria Math"/>
-                      </a:rPr>
-                      <m:t>0</m:t>
-                    </m:r>
-                    <m:r>
-                      <a:rPr lang="en-US" i="1">
-                        <a:latin typeface="Cambria Math"/>
-                      </a:rPr>
-                      <m:t>,</m:t>
+                      <m:t>=0,</m:t>
                     </m:r>
                     <m:sSub>
                       <m:sSubPr>
@@ -6169,13 +6151,7 @@
                       <a:rPr lang="en-US" i="1">
                         <a:latin typeface="Cambria Math"/>
                       </a:rPr>
-                      <m:t>−</m:t>
-                    </m:r>
-                    <m:r>
-                      <a:rPr lang="en-US" i="1">
-                        <a:latin typeface="Cambria Math"/>
-                      </a:rPr>
-                      <m:t>1</m:t>
+                      <m:t>−1</m:t>
                     </m:r>
                   </m:oMath>
                 </a14:m>
@@ -6283,13 +6259,7 @@
                       <a:rPr lang="en-US" i="1">
                         <a:latin typeface="Cambria Math"/>
                       </a:rPr>
-                      <m:t>0</m:t>
-                    </m:r>
-                    <m:r>
-                      <a:rPr lang="en-US" i="1">
-                        <a:latin typeface="Cambria Math"/>
-                      </a:rPr>
-                      <m:t>≤</m:t>
+                      <m:t>0≤</m:t>
                     </m:r>
                     <m:sSub>
                       <m:sSubPr>
@@ -6877,19 +6847,7 @@
                       <a:rPr lang="en-US" i="1">
                         <a:latin typeface="Cambria Math"/>
                       </a:rPr>
-                      <m:t>∈[</m:t>
-                    </m:r>
-                    <m:r>
-                      <a:rPr lang="en-US" i="1">
-                        <a:latin typeface="Cambria Math"/>
-                      </a:rPr>
-                      <m:t>0</m:t>
-                    </m:r>
-                    <m:r>
-                      <a:rPr lang="en-US" i="1">
-                        <a:latin typeface="Cambria Math"/>
-                      </a:rPr>
-                      <m:t>,</m:t>
+                      <m:t>∈[0,</m:t>
                     </m:r>
                     <m:r>
                       <a:rPr lang="en-US" i="1">
@@ -6901,19 +6859,7 @@
                       <a:rPr lang="en-US" i="1">
                         <a:latin typeface="Cambria Math"/>
                       </a:rPr>
-                      <m:t>−</m:t>
-                    </m:r>
-                    <m:r>
-                      <a:rPr lang="en-US" i="1">
-                        <a:latin typeface="Cambria Math"/>
-                      </a:rPr>
-                      <m:t>1</m:t>
-                    </m:r>
-                    <m:r>
-                      <a:rPr lang="en-US" i="1">
-                        <a:latin typeface="Cambria Math"/>
-                      </a:rPr>
-                      <m:t>],−</m:t>
+                      <m:t>−1],−</m:t>
                     </m:r>
                     <m:r>
                       <a:rPr lang="en-US" i="1">
@@ -6925,13 +6871,13 @@
                       <a:rPr lang="en-US" i="1">
                         <a:latin typeface="Cambria Math"/>
                       </a:rPr>
-                      <m:t>/</m:t>
-                    </m:r>
-                    <m:r>
-                      <a:rPr lang="en-US" i="1">
-                        <a:latin typeface="Cambria Math"/>
-                      </a:rPr>
-                      <m:t>2</m:t>
+                      <m:t>/2≤</m:t>
+                    </m:r>
+                    <m:r>
+                      <a:rPr lang="en-US" i="1">
+                        <a:latin typeface="Cambria Math"/>
+                      </a:rPr>
+                      <m:t>𝑧</m:t>
                     </m:r>
                     <m:r>
                       <a:rPr lang="en-US" i="1">
@@ -6943,31 +6889,13 @@
                       <a:rPr lang="en-US" i="1">
                         <a:latin typeface="Cambria Math"/>
                       </a:rPr>
-                      <m:t>𝑧</m:t>
-                    </m:r>
-                    <m:r>
-                      <a:rPr lang="en-US" i="1">
-                        <a:latin typeface="Cambria Math"/>
-                      </a:rPr>
-                      <m:t>≤</m:t>
-                    </m:r>
-                    <m:r>
-                      <a:rPr lang="en-US" i="1">
-                        <a:latin typeface="Cambria Math"/>
-                      </a:rPr>
                       <m:t>𝛼</m:t>
                     </m:r>
                     <m:r>
                       <a:rPr lang="en-US" i="1">
                         <a:latin typeface="Cambria Math"/>
                       </a:rPr>
-                      <m:t>/</m:t>
-                    </m:r>
-                    <m:r>
-                      <a:rPr lang="en-US" i="1">
-                        <a:latin typeface="Cambria Math"/>
-                      </a:rPr>
-                      <m:t>2</m:t>
+                      <m:t>/2</m:t>
                     </m:r>
                   </m:oMath>
                 </a14:m>
@@ -7029,13 +6957,7 @@
                                   <a:rPr lang="en-US" i="1">
                                     <a:latin typeface="Cambria Math"/>
                                   </a:rPr>
-                                  <m:t>1</m:t>
-                                </m:r>
-                                <m:r>
-                                  <a:rPr lang="en-US" i="1">
-                                    <a:latin typeface="Cambria Math"/>
-                                  </a:rPr>
-                                  <m:t>,</m:t>
+                                  <m:t>1,</m:t>
                                 </m:r>
                               </m:e>
                               <m:e>
@@ -7137,13 +7059,7 @@
                                   <a:rPr lang="en-US" i="1">
                                     <a:latin typeface="Cambria Math"/>
                                   </a:rPr>
-                                  <m:t>0</m:t>
-                                </m:r>
-                                <m:r>
-                                  <a:rPr lang="en-US" i="1">
-                                    <a:latin typeface="Cambria Math"/>
-                                  </a:rPr>
-                                  <m:t>,</m:t>
+                                  <m:t>0,</m:t>
                                 </m:r>
                               </m:e>
                               <m:e>
@@ -21980,19 +21896,7 @@
                             <a:rPr lang="en-US" i="1">
                               <a:latin typeface="Cambria Math"/>
                             </a:rPr>
-                            <m:t>(</m:t>
-                          </m:r>
-                          <m:r>
-                            <a:rPr lang="en-US" i="1">
-                              <a:latin typeface="Cambria Math"/>
-                            </a:rPr>
-                            <m:t>1</m:t>
-                          </m:r>
-                          <m:r>
-                            <a:rPr lang="en-US" i="1">
-                              <a:latin typeface="Cambria Math"/>
-                            </a:rPr>
-                            <m:t>−</m:t>
+                            <m:t>(1−</m:t>
                           </m:r>
                           <m:f>
                             <m:fPr>
@@ -22013,25 +21917,7 @@
                                 <a:rPr lang="en-US" i="1">
                                   <a:latin typeface="Cambria Math"/>
                                 </a:rPr>
-                                <m:t>+</m:t>
-                              </m:r>
-                              <m:r>
-                                <a:rPr lang="en-US" i="1">
-                                  <a:latin typeface="Cambria Math"/>
-                                </a:rPr>
-                                <m:t>1</m:t>
-                              </m:r>
-                              <m:r>
-                                <a:rPr lang="en-US" i="1">
-                                  <a:latin typeface="Cambria Math"/>
-                                </a:rPr>
-                                <m:t>/</m:t>
-                              </m:r>
-                              <m:r>
-                                <a:rPr lang="en-US" i="1">
-                                  <a:latin typeface="Cambria Math"/>
-                                </a:rPr>
-                                <m:t>2</m:t>
+                                <m:t>+1/2</m:t>
                               </m:r>
                             </m:num>
                             <m:den>
@@ -22074,13 +21960,7 @@
                             <a:rPr lang="en-US" i="1">
                               <a:latin typeface="Cambria Math"/>
                             </a:rPr>
-                            <m:t>256</m:t>
-                          </m:r>
-                          <m:r>
-                            <a:rPr lang="en-US" i="1">
-                              <a:latin typeface="Cambria Math"/>
-                            </a:rPr>
-                            <m:t>ℓ</m:t>
+                            <m:t>256ℓ</m:t>
                           </m:r>
                         </m:sup>
                       </m:sSup>
@@ -22111,19 +21991,7 @@
                             <a:rPr lang="en-US" i="1">
                               <a:latin typeface="Cambria Math"/>
                             </a:rPr>
-                            <m:t>−</m:t>
-                          </m:r>
-                          <m:r>
-                            <a:rPr lang="en-US" i="1">
-                              <a:latin typeface="Cambria Math"/>
-                            </a:rPr>
-                            <m:t>256</m:t>
-                          </m:r>
-                          <m:r>
-                            <a:rPr lang="en-US" i="1">
-                              <a:latin typeface="Cambria Math"/>
-                            </a:rPr>
-                            <m:t>ℓ</m:t>
+                            <m:t>−256ℓ</m:t>
                           </m:r>
                           <m:r>
                             <a:rPr lang="en-US" i="1">
@@ -22337,19 +22205,7 @@
                             <a:rPr lang="en-US" i="1">
                               <a:latin typeface="Cambria Math"/>
                             </a:rPr>
-                            <m:t>(</m:t>
-                          </m:r>
-                          <m:r>
-                            <a:rPr lang="en-US" i="1">
-                              <a:latin typeface="Cambria Math"/>
-                            </a:rPr>
-                            <m:t>1</m:t>
-                          </m:r>
-                          <m:r>
-                            <a:rPr lang="en-US" i="1">
-                              <a:latin typeface="Cambria Math"/>
-                            </a:rPr>
-                            <m:t>−</m:t>
+                            <m:t>(1−</m:t>
                           </m:r>
                           <m:f>
                             <m:fPr>
@@ -22370,25 +22226,7 @@
                                 <a:rPr lang="en-US" i="1">
                                   <a:latin typeface="Cambria Math"/>
                                 </a:rPr>
-                                <m:t>+</m:t>
-                              </m:r>
-                              <m:r>
-                                <a:rPr lang="en-US" i="1">
-                                  <a:latin typeface="Cambria Math"/>
-                                </a:rPr>
-                                <m:t>1</m:t>
-                              </m:r>
-                              <m:r>
-                                <a:rPr lang="en-US" i="1">
-                                  <a:latin typeface="Cambria Math"/>
-                                </a:rPr>
-                                <m:t>/</m:t>
-                              </m:r>
-                              <m:r>
-                                <a:rPr lang="en-US" i="1">
-                                  <a:latin typeface="Cambria Math"/>
-                                </a:rPr>
-                                <m:t>2</m:t>
+                                <m:t>+1/2</m:t>
                               </m:r>
                             </m:num>
                             <m:den>
@@ -22468,13 +22306,7 @@
                             <a:rPr lang="en-US" i="1">
                               <a:latin typeface="Cambria Math"/>
                             </a:rPr>
-                            <m:t>−</m:t>
-                          </m:r>
-                          <m:r>
-                            <a:rPr lang="en-US" i="1">
-                              <a:latin typeface="Cambria Math"/>
-                            </a:rPr>
-                            <m:t>256</m:t>
+                            <m:t>−256</m:t>
                           </m:r>
                           <m:r>
                             <a:rPr lang="en-US" i="1">
@@ -25042,19 +24874,7 @@
                       <a:rPr lang="en-US" i="1">
                         <a:latin typeface="Cambria Math"/>
                       </a:rPr>
-                      <m:t>∈[</m:t>
-                    </m:r>
-                    <m:r>
-                      <a:rPr lang="en-US" i="1">
-                        <a:latin typeface="Cambria Math"/>
-                      </a:rPr>
-                      <m:t>0</m:t>
-                    </m:r>
-                    <m:r>
-                      <a:rPr lang="en-US" i="1">
-                        <a:latin typeface="Cambria Math"/>
-                      </a:rPr>
-                      <m:t>,</m:t>
+                      <m:t>∈[0,</m:t>
                     </m:r>
                     <m:r>
                       <a:rPr lang="en-US" i="1">
@@ -25066,19 +24886,7 @@
                       <a:rPr lang="en-US" i="1">
                         <a:latin typeface="Cambria Math"/>
                       </a:rPr>
-                      <m:t>−</m:t>
-                    </m:r>
-                    <m:r>
-                      <a:rPr lang="en-US" i="1">
-                        <a:latin typeface="Cambria Math"/>
-                      </a:rPr>
-                      <m:t>1</m:t>
-                    </m:r>
-                    <m:r>
-                      <a:rPr lang="en-US" i="1">
-                        <a:latin typeface="Cambria Math"/>
-                      </a:rPr>
-                      <m:t>]</m:t>
+                      <m:t>−1]</m:t>
                     </m:r>
                   </m:oMath>
                 </a14:m>
@@ -25098,19 +24906,7 @@
                       <a:rPr lang="en-US" i="1">
                         <a:latin typeface="Cambria Math"/>
                       </a:rPr>
-                      <m:t>∈[</m:t>
-                    </m:r>
-                    <m:r>
-                      <a:rPr lang="en-US" i="1">
-                        <a:latin typeface="Cambria Math"/>
-                      </a:rPr>
-                      <m:t>1</m:t>
-                    </m:r>
-                    <m:r>
-                      <a:rPr lang="en-US" i="1">
-                        <a:latin typeface="Cambria Math"/>
-                      </a:rPr>
-                      <m:t>,</m:t>
+                      <m:t>∈[1,</m:t>
                     </m:r>
                     <m:sSub>
                       <m:sSubPr>
@@ -25380,13 +25176,7 @@
                             <a:rPr lang="en-US" i="1">
                               <a:latin typeface="Cambria Math"/>
                             </a:rPr>
-                            <m:t>−</m:t>
-                          </m:r>
-                          <m:r>
-                            <a:rPr lang="en-US" i="1">
-                              <a:latin typeface="Cambria Math"/>
-                            </a:rPr>
-                            <m:t>1</m:t>
+                            <m:t>−1</m:t>
                           </m:r>
                         </m:sup>
                       </m:sSup>
@@ -25454,13 +25244,7 @@
                             <a:rPr lang="en-US" i="1">
                               <a:latin typeface="Cambria Math"/>
                             </a:rPr>
-                            <m:t>−</m:t>
-                          </m:r>
-                          <m:r>
-                            <a:rPr lang="en-US" i="1">
-                              <a:latin typeface="Cambria Math"/>
-                            </a:rPr>
-                            <m:t>1</m:t>
+                            <m:t>−1</m:t>
                           </m:r>
                         </m:sup>
                       </m:sSup>
@@ -25468,19 +25252,7 @@
                         <a:rPr lang="en-US" i="1">
                           <a:latin typeface="Cambria Math"/>
                         </a:rPr>
-                        <m:t>,</m:t>
-                      </m:r>
-                      <m:r>
-                        <a:rPr lang="en-US" i="1">
-                          <a:latin typeface="Cambria Math"/>
-                        </a:rPr>
-                        <m:t>0</m:t>
-                      </m:r>
-                      <m:r>
-                        <a:rPr lang="en-US" i="1">
-                          <a:latin typeface="Cambria Math"/>
-                        </a:rPr>
-                        <m:t>≤</m:t>
+                        <m:t>,0≤</m:t>
                       </m:r>
                       <m:sSub>
                         <m:sSubPr>
@@ -25540,19 +25312,7 @@
                             <a:rPr lang="en-US" i="1">
                               <a:latin typeface="Cambria Math"/>
                             </a:rPr>
-                            <m:t>−</m:t>
-                          </m:r>
-                          <m:r>
-                            <a:rPr lang="en-US" i="1">
-                              <a:latin typeface="Cambria Math"/>
-                            </a:rPr>
-                            <m:t>1</m:t>
-                          </m:r>
-                          <m:r>
-                            <a:rPr lang="en-US" i="1">
-                              <a:latin typeface="Cambria Math"/>
-                            </a:rPr>
-                            <m:t>)/</m:t>
+                            <m:t>−1)/</m:t>
                           </m:r>
                           <m:sSup>
                             <m:sSupPr>
@@ -31865,8 +31625,8 @@
           </a:p>
         </p:txBody>
       </p:sp>
-      <mc:AlternateContent xmlns:mc="http://schemas.openxmlformats.org/markup-compatibility/2006" xmlns:a14="http://schemas.microsoft.com/office/drawing/2010/main">
-        <mc:Choice Requires="a14">
+      <mc:AlternateContent xmlns:mc="http://schemas.openxmlformats.org/markup-compatibility/2006">
+        <mc:Choice xmlns:a14="http://schemas.microsoft.com/office/drawing/2010/main" Requires="a14">
           <p:sp>
             <p:nvSpPr>
               <p:cNvPr id="3" name="Content Placeholder 2"/>
@@ -31889,7 +31649,23 @@
               <a:p>
                 <a:r>
                   <a:rPr dirty="0"/>
-                  <a:t>이제 검증자는 t1만 알고 t0는 모른다. </a:t>
+                  <a:t>이제 검증자는 t</a:t>
+                </a:r>
+                <a:r>
+                  <a:rPr baseline="-25000" dirty="0"/>
+                  <a:t>1</a:t>
+                </a:r>
+                <a:r>
+                  <a:rPr dirty="0"/>
+                  <a:t>만 알고 t</a:t>
+                </a:r>
+                <a:r>
+                  <a:rPr baseline="-25000" dirty="0"/>
+                  <a:t>0</a:t>
+                </a:r>
+                <a:r>
+                  <a:rPr dirty="0"/>
+                  <a:t>는 모른다. </a:t>
                 </a:r>
                 <a14:m>
                   <m:oMath xmlns:m="http://schemas.openxmlformats.org/officeDocument/2006/math">
@@ -32371,7 +32147,7 @@
             </p:txBody>
           </p:sp>
         </mc:Choice>
-        <mc:Fallback xmlns="">
+        <mc:Fallback>
           <p:sp>
             <p:nvSpPr>
               <p:cNvPr id="3" name="Content Placeholder 2"/>

</xml_diff>